<commit_message>
fix: corrige la régression EditSaisieModal et le nombre réel de sous-émotions
Suite à la revue par agents :
- EditSaisieModal : réinitialise prevSaisieId à la fermeture (saisie=null) pour
  que la réouverture de la MÊME saisie réaffiche ses valeurs d'origine
  (régression introduite par le passage de useEffect à l'ajustement d'état)
- corrige le nombre de sous-émotions 28 -> 33 (compte réel du seeder :
  6+5+5+5+4+4+4) dans le dossier, les slides, le plan d'oral et CLAUDE.md
- régénère le cahier des charges (19 p.) et le support de soutenance (16 slides)

Co-Authored-By: Claude Opus 4.8 (1M context) <noreply@anthropic.com>
</commit_message>
<xml_diff>
--- a/CESIZen_Soutenance.pptx
+++ b/CESIZen_Soutenance.pptx
@@ -7678,7 +7678,7 @@
                 </a:solidFill>
                 <a:latin typeface="Arial"/>
               </a:rPr>
-              <a:t>•  Hiérarchie : 7 émotions de base + 28 sous-émotions.</a:t>
+              <a:t>•  Hiérarchie : 7 émotions de base + 33 sous-émotions.</a:t>
             </a:r>
           </a:p>
         </p:txBody>
@@ -9955,7 +9955,7 @@
                 </a:solidFill>
                 <a:latin typeface="Arial"/>
               </a:rPr>
-              <a:t>•  Hiérarchie configurable par l'admin : 7 émotions + 28 sous-émotions.</a:t>
+              <a:t>•  Hiérarchie configurable par l'admin : 7 émotions + 33 sous-émotions.</a:t>
             </a:r>
           </a:p>
           <a:p>

</xml_diff>

<commit_message>
fix: aligne le référentiel d'émotions sur le sujet et complète le dossier
Référentiel d'émotions (conformité au sujet) :
- 6 émotions de base (suppression d'« Amour ») et 36 sous-émotions
- libellés exacts du sujet (Surprise dédupliquée : Étonnement listé 2x)
- propagation du décompte 6+36 (CLAUDE.md, plan oral, slides, dossier, mobile)

Corrections dossier (grille d'évaluation Bloc INFCDAAL1) :
- ajout d'un sommaire
- contraintes budget 75 000 EUR et délai 12 mois (chiffres du sujet)
- table des parties prenantes et de leur communication (§4.1)
- mockup du module Informations (les 3 modules ont désormais une maquette)
- cardinalités du MCD agrandies et lisibles
- chiffrement reformulé honnêtement (bcrypt aujourd'hui, AES-256 prévu en prod HDS)
- dossier maintenu à 20 pages (limite respectée)

Vérifs : backend 15 tests, mobile tsc 0, seeder 6+36.

Co-Authored-By: Claude Opus 4.8 (1M context) <noreply@anthropic.com>
</commit_message>
<xml_diff>
--- a/CESIZen_Soutenance.pptx
+++ b/CESIZen_Soutenance.pptx
@@ -4593,7 +4593,7 @@
                 </a:solidFill>
                 <a:latin typeface="Arial"/>
               </a:rPr>
-              <a:t>•  Chiffrement en transit (HTTPS/TLS 1.3) et au repos (AES-256).</a:t>
+              <a:t>•  Chiffrement en transit (HTTPS/TLS 1.3) ; bcrypt sur les mots de passe, AES-256 au repos prévu en prod HDS.</a:t>
             </a:r>
           </a:p>
           <a:p>
@@ -7678,7 +7678,7 @@
                 </a:solidFill>
                 <a:latin typeface="Arial"/>
               </a:rPr>
-              <a:t>•  Hiérarchie : 7 émotions de base + 33 sous-émotions.</a:t>
+              <a:t>•  Hiérarchie : 6 émotions de base + 36 sous-émotions (référentiel du sujet).</a:t>
             </a:r>
           </a:p>
         </p:txBody>
@@ -9955,7 +9955,7 @@
                 </a:solidFill>
                 <a:latin typeface="Arial"/>
               </a:rPr>
-              <a:t>•  Hiérarchie configurable par l'admin : 7 émotions + 33 sous-émotions.</a:t>
+              <a:t>•  Hiérarchie configurable par l'admin : 6 émotions + 36 sous-émotions.</a:t>
             </a:r>
           </a:p>
           <a:p>

</xml_diff>